<commit_message>
plans/ppt：投影片改用 DSH（DeepSeek Harness），取代 opencode 內容
- 品牌/工具：Opencode/opencode → DSH（標題頁、章節頁、內文與講稿）
- 啟動方式改成 DSH：dsh_web（＝pnpm dsh web）→ 瀏覽器開 http://127.0.0.1:3080；
  Web 介面左側 session 清單接續對話；不再有 /exit /init /finmind /start-work 等舊指令
- 模型段落改成 deepseek-flash（可在 Web 介面切換；同一段對話不混用他廠模型）
- 舊模式（Sisyphus / Prometheus Plan Builder / Ultraworker）改成 DSH 的 plan 模式
  （先送計畫核准再動手）＋ goal（長任務分回合續跑）
- 技能（skills）改成自然語言呼叫（例：用 finmind 抓月營收）
- W1 準備清單第二項從「申請 OpenRouter」改成「使用 DSH＋deepseek-flash，金鑰事先設好」
- 路徑：~/tw-autotrader → ~/tw-selfselect（VM 名稱 tw-autotrader 與 GitHub URL 保留）
- W3 操作頁（s2–s6）文字框整段重寫，避免舊行殘留；W5 s17 講稿「切到 Deepseek Pro」→「換更大模型續跑」
- 掃描全文字（含講稿）禁用詞 0 命中

註：部分頁面的「截圖」仍是舊 opencode UI，尚未替換（需 DSH 介面截圖）。
</commit_message>
<xml_diff>
--- a/plans/ppt/TW-SELFSELECT台股買賣自動化系統-W1-講稿版.pptx
+++ b/plans/ppt/TW-SELFSELECT台股買賣自動化系統-W1-講稿版.pptx
@@ -3206,7 +3206,7 @@
           </a:p>
           <a:p>
             <a:r>
-              <a:t>這套系統，是用 Python 搭配 Opencode AI 打造的——簡單說，就是讓電腦幫你看盤、幫你下單、用 Telegram 通知你買賣。</a:t>
+              <a:t>這套系統，是用 Python 搭配 DSH AI 打造的——簡單說，就是讓電腦幫你看盤、幫你下單、用 Telegram 通知你買賣。</a:t>
             </a:r>
           </a:p>
           <a:p>
@@ -3319,7 +3319,7 @@
           </a:p>
           <a:p>
             <a:r>
-              <a:t>我問 Opencode：我預期某檔股票——我們姑且叫它 XX——股價還會上升，該用什麼策略？</a:t>
+              <a:t>我問 DSH：我預期某檔股票——我們姑且叫它 XX——股價還會上升，該用什麼策略？</a:t>
             </a:r>
           </a:p>
           <a:p>
@@ -3436,7 +3436,7 @@
           </a:p>
           <a:p>
             <a:r>
-              <a:t>最後我要強調兩件事：第一，這是在 Opencode 中的 AI 問答，不是一般對話型 AI——Opencode 會先掃描專案內所有檔案，才能針對這個專案回答；第二，AI 說的不全對，但是很有參考價值。這是我們面對 AI 建議該有的心態。</a:t>
+              <a:t>最後我要強調兩件事：第一，這是在 DSH 中的 AI 問答，不是一般對話型 AI——DSH 會先掃描專案內所有檔案，才能針對這個專案回答；第二，AI 說的不全對，但是很有參考價值。這是我們面對 AI 建議該有的心態。</a:t>
             </a:r>
           </a:p>
           <a:p>
@@ -3533,7 +3533,7 @@
           </a:p>
           <a:p>
             <a:r>
-              <a:t>第二，申請 OpenRouter 帳戶，先儲值個 20 美金，用完再加——這是用來呼叫 AI 的，另外申請 Nvidia 帳號備用；</a:t>
+              <a:t>第二，AI 服務：本課程使用 DSH（DeepSeek Harness）＋deepseek-flash，金鑰事先設好，不需要另外申請；</a:t>
             </a:r>
           </a:p>
           <a:p>
@@ -3549,11 +3549,6 @@
           <a:p>
             <a:r>
               <a:t>第五，在你的電腦上安裝 VSCode，記得裝 WSL 和 Markdown All in One 插件，然後在 CMD 底下執行 wsl --install 安裝 WSL。手機上要裝 Telegram，並申請 Bot Token。</a:t>
-            </a:r>
-          </a:p>
-          <a:p>
-            <a:r>
-              <a:t>---</a:t>
             </a:r>
           </a:p>
           <a:p/>
@@ -4145,7 +4140,7 @@
           </a:p>
           <a:p>
             <a:r>
-              <a:t>今天的內容包括：簡單認識我、系統簡介、什麼是 Python、什麼是 Opencode，接著會介紹系統內建的五大策略、怎麼回測、最後是實盤執行。</a:t>
+              <a:t>今天的內容包括：簡單認識我、系統簡介、什麼是 Python、什麼是 DSH，接著會介紹系統內建的五大策略、怎麼回測、最後是實盤執行。</a:t>
             </a:r>
           </a:p>
           <a:p>
@@ -4481,7 +4476,7 @@
           </a:p>
           <a:p>
             <a:r>
-              <a:t>最後，我們會給你一份完整的 WSL 壓縮檔，所有 Python、Opencode 等工具都已經安裝好了，打開就能用。</a:t>
+              <a:t>最後，我們會給你一份完整的 WSL 壓縮檔，所有 Python、DSH 等工具都已經安裝好了，打開就能用。</a:t>
             </a:r>
           </a:p>
           <a:p>
@@ -4777,12 +4772,12 @@
           <a:p/>
           <a:p>
             <a:r>
-              <a:t>在進入正題之前，我先給大家看兩個例子，讓你們感受一下「Opencode 加上 Finmind」到底能做到什麼程度。</a:t>
-            </a:r>
-          </a:p>
-          <a:p>
-            <a:r>
-              <a:t>我請 Opencode 幫我做一個「台灣 2026 年前十大 EPS 公司走勢」的 HTML 網頁。</a:t>
+              <a:t>在進入正題之前，我先給大家看兩個例子，讓你們感受一下「DSH 加上 Finmind」到底能做到什麼程度。</a:t>
+            </a:r>
+          </a:p>
+          <a:p>
+            <a:r>
+              <a:t>我請 DSH 幫我做一個「台灣 2026 年前十大 EPS 公司走勢」的 HTML 網頁。</a:t>
             </a:r>
           </a:p>
           <a:p>
@@ -4900,7 +4895,7 @@
           <a:p/>
           <a:p>
             <a:r>
-              <a:t>【講師提示】強調「複合條件一句話完成」，這是 Opencode 工作流的精髓預告。</a:t>
+              <a:t>【講師提示】強調「複合條件一句話完成」，這是 DSH 工作流的精髓預告。</a:t>
             </a:r>
           </a:p>
         </p:txBody>
@@ -12680,23 +12675,23 @@
           <a:p>
             <a:r>
               <a:rPr lang="zh-TW" altLang="en-US" dirty="0"/>
-              <a:t>使用</a:t>
+              <a:t>使用 Python 與 DSH</a:t>
             </a:r>
             <a:r>
               <a:rPr lang="en-US" altLang="zh-TW" dirty="0"/>
-              <a:t>Python</a:t>
+              <a:t/>
             </a:r>
             <a:r>
               <a:rPr lang="zh-TW" altLang="en-US" dirty="0"/>
-              <a:t>與</a:t>
+              <a:t/>
             </a:r>
             <a:r>
               <a:rPr lang="en-US" altLang="zh-TW" dirty="0" err="1"/>
-              <a:t>Opencode</a:t>
+              <a:t/>
             </a:r>
             <a:r>
               <a:rPr lang="en-US" altLang="zh-TW" dirty="0"/>
-              <a:t> AI</a:t>
+              <a:t/>
             </a:r>
             <a:endParaRPr lang="en-US" dirty="0"/>
           </a:p>
@@ -12760,27 +12755,27 @@
           <a:p>
             <a:r>
               <a:rPr lang="zh-TW" altLang="en-US" dirty="0"/>
-              <a:t>與</a:t>
+              <a:t>deepseek-flash</a:t>
             </a:r>
             <a:r>
               <a:rPr lang="en-US" altLang="zh-TW" dirty="0"/>
-              <a:t>AI(</a:t>
+              <a:t/>
             </a:r>
             <a:r>
               <a:rPr lang="en-US" altLang="zh-TW" dirty="0" err="1"/>
-              <a:t>Deepseek</a:t>
+              <a:t/>
             </a:r>
             <a:r>
               <a:rPr lang="en-US" altLang="zh-TW" dirty="0"/>
-              <a:t> R4 Flash)</a:t>
+              <a:t/>
             </a:r>
             <a:r>
               <a:rPr lang="zh-TW" altLang="en-US" dirty="0"/>
-              <a:t>討論策略</a:t>
+              <a:t/>
             </a:r>
             <a:r>
               <a:rPr lang="en-US" altLang="zh-TW" dirty="0"/>
-              <a:t>-1</a:t>
+              <a:t/>
             </a:r>
             <a:endParaRPr lang="en-US" dirty="0"/>
           </a:p>
@@ -13128,27 +13123,27 @@
           <a:p>
             <a:r>
               <a:rPr lang="zh-TW" altLang="en-US" dirty="0"/>
-              <a:t>與</a:t>
+              <a:t>deepseek-flash</a:t>
             </a:r>
             <a:r>
               <a:rPr lang="en-US" altLang="zh-TW" dirty="0"/>
-              <a:t>AI(</a:t>
+              <a:t/>
             </a:r>
             <a:r>
               <a:rPr lang="en-US" altLang="zh-TW" dirty="0" err="1"/>
-              <a:t>Deepseek</a:t>
+              <a:t/>
             </a:r>
             <a:r>
               <a:rPr lang="en-US" altLang="zh-TW" dirty="0"/>
-              <a:t> R4 Flash)</a:t>
+              <a:t/>
             </a:r>
             <a:r>
               <a:rPr lang="zh-TW" altLang="en-US" dirty="0"/>
-              <a:t>討論策略</a:t>
+              <a:t/>
             </a:r>
             <a:r>
               <a:rPr lang="en-US" altLang="zh-TW" dirty="0"/>
-              <a:t>-2</a:t>
+              <a:t/>
             </a:r>
             <a:endParaRPr lang="en-US" dirty="0"/>
           </a:p>
@@ -13433,7 +13428,7 @@
                   <a:srgbClr val="FF0000"/>
                 </a:solidFill>
               </a:rPr>
-              <a:t>Opencode</a:t>
+              <a:t>DSH</a:t>
             </a:r>
             <a:r>
               <a:rPr lang="zh-TW" altLang="en-US" b="1" dirty="0">
@@ -13513,7 +13508,7 @@
                   <a:srgbClr val="FF0000"/>
                 </a:solidFill>
               </a:rPr>
-              <a:t>Opencode</a:t>
+              <a:t>DSH</a:t>
             </a:r>
             <a:r>
               <a:rPr lang="zh-TW" altLang="en-US" b="1" dirty="0">
@@ -13902,61 +13897,61 @@
                         <a:rPr lang="en-US" sz="3300" dirty="0" err="1">
                           <a:hlinkClick r:id="rId3"/>
                         </a:rPr>
-                        <a:t>Openrouter</a:t>
+                        <a:t>（本課程統一用 DeepSeek 官方模型，避免金鑰與計費混亂）</a:t>
                       </a:r>
                       <a:r>
                         <a:rPr lang="zh-TW" altLang="en-US" sz="3300" dirty="0"/>
-                        <a:t>帳戶</a:t>
+                        <a:t/>
                       </a:r>
                       <a:r>
                         <a:rPr lang="en-US" altLang="zh-TW" sz="3300" dirty="0"/>
-                        <a:t>(</a:t>
+                        <a:t/>
                       </a:r>
                       <a:r>
                         <a:rPr lang="zh-TW" altLang="en-US" sz="3300" dirty="0"/>
-                        <a:t>並充個</a:t>
+                        <a:t/>
                       </a:r>
                       <a:r>
                         <a:rPr lang="en-US" altLang="zh-TW" sz="3300" dirty="0"/>
-                        <a:t>20</a:t>
+                        <a:t/>
                       </a:r>
                       <a:r>
                         <a:rPr lang="zh-TW" altLang="en-US" sz="3300" dirty="0"/>
-                        <a:t>美金</a:t>
+                        <a:t/>
                       </a:r>
                       <a:r>
                         <a:rPr lang="en-US" altLang="zh-TW" sz="3300" dirty="0"/>
-                        <a:t>,</a:t>
+                        <a:t/>
                       </a:r>
                       <a:r>
                         <a:rPr lang="zh-TW" altLang="en-US" sz="3300" dirty="0"/>
-                        <a:t>用完再加</a:t>
+                        <a:t/>
                       </a:r>
                       <a:r>
                         <a:rPr lang="en-US" altLang="zh-TW" sz="3300" dirty="0"/>
-                        <a:t>)</a:t>
+                        <a:t/>
                       </a:r>
                       <a:r>
                         <a:rPr lang="zh-TW" altLang="en-US" sz="3300" dirty="0"/>
-                        <a:t>以使用</a:t>
+                        <a:t/>
                       </a:r>
                       <a:r>
                         <a:rPr lang="en-US" altLang="zh-TW" sz="3300" dirty="0"/>
-                        <a:t>AI,</a:t>
+                        <a:t/>
                       </a:r>
                       <a:r>
                         <a:rPr lang="zh-TW" altLang="en-US" sz="3300" dirty="0"/>
-                        <a:t> 並申請</a:t>
+                        <a:t/>
                       </a:r>
                       <a:r>
                         <a:rPr lang="en-US" altLang="zh-TW" sz="3300" dirty="0">
                           <a:hlinkClick r:id="rId4"/>
                         </a:rPr>
-                        <a:t>Nvidia</a:t>
+                        <a:t/>
                       </a:r>
                       <a:r>
                         <a:rPr lang="zh-TW" altLang="en-US" sz="3300" dirty="0"/>
-                        <a:t>帳號備用</a:t>
+                        <a:t/>
                       </a:r>
                       <a:endParaRPr lang="en-US" sz="3300" dirty="0"/>
                     </a:p>
@@ -16758,11 +16753,11 @@
           <a:p>
             <a:r>
               <a:rPr lang="zh-TW" altLang="en-US" dirty="0"/>
-              <a:t>關於</a:t>
+              <a:t>關於 DSH</a:t>
             </a:r>
             <a:r>
               <a:rPr lang="en-US" altLang="zh-TW" dirty="0" err="1"/>
-              <a:t>Opencode</a:t>
+              <a:t/>
             </a:r>
             <a:endParaRPr lang="en-US" dirty="0"/>
           </a:p>
@@ -17645,7 +17640,7 @@
             </a:r>
             <a:r>
               <a:rPr lang="en-US" altLang="zh-TW" dirty="0" err="1"/>
-              <a:t>Opencode</a:t>
+              <a:t>DSH</a:t>
             </a:r>
             <a:r>
               <a:rPr lang="en-US" altLang="zh-TW" dirty="0"/>
@@ -18266,7 +18261,7 @@
           <a:p>
             <a:r>
               <a:rPr lang="en-US" altLang="zh-TW" dirty="0" err="1"/>
-              <a:t>Opencode+Finmind</a:t>
+              <a:t>DSH + Finmind</a:t>
             </a:r>
             <a:r>
               <a:rPr lang="zh-TW" altLang="en-US" dirty="0"/>
@@ -18512,7 +18507,7 @@
           <a:p>
             <a:r>
               <a:rPr lang="en-US" altLang="zh-TW" dirty="0" err="1"/>
-              <a:t>Opencode+Finmind</a:t>
+              <a:t>DSH + Finmind</a:t>
             </a:r>
             <a:r>
               <a:rPr lang="zh-TW" altLang="en-US" dirty="0"/>

</xml_diff>